<commit_message>
Docs: Update project presentation uploaded
</commit_message>
<xml_diff>
--- a/docs/Presentation - Recommendation Systems. Theoretical Approaches.pptx
+++ b/docs/Presentation - Recommendation Systems. Theoretical Approaches.pptx
@@ -1715,8 +1715,8 @@
               <a:t> </a:t>
             </a:r>
             <a:r>
-              <a:rPr lang="uk-UA" dirty="0" err="1"/>
-              <a:t>користуваче</a:t>
+              <a:rPr lang="uk-UA" dirty="0"/>
+              <a:t>користувачем</a:t>
             </a:r>
             <a:r>
               <a:rPr lang="en-US" dirty="0"/>
@@ -2221,8 +2221,8 @@
               <a:t> та </a:t>
             </a:r>
             <a:r>
-              <a:rPr lang="uk-UA" noProof="0" dirty="0" err="1"/>
-              <a:t>Twitter</a:t>
+              <a:rPr lang="en-US" noProof="0" dirty="0"/>
+              <a:t>X</a:t>
             </a:r>
             <a:r>
               <a:rPr lang="uk-UA" noProof="0" dirty="0"/>
@@ -5767,7 +5767,7 @@
           <a:p>
             <a:r>
               <a:rPr lang="uk-UA" b="1" dirty="0"/>
-              <a:t>Доцільно, мабуть, почати з </a:t>
+              <a:t>Мабуть, почнемо з </a:t>
             </a:r>
             <a:r>
               <a:rPr lang="uk-UA" b="1" dirty="0" err="1"/>
@@ -6463,15 +6463,7 @@
             </a:r>
             <a:r>
               <a:rPr lang="uk-UA" noProof="0" dirty="0"/>
-              <a:t>— генерація рекомендацій. Досить </a:t>
-            </a:r>
-            <a:r>
-              <a:rPr lang="uk-UA" noProof="0" dirty="0" err="1"/>
-              <a:t>частом</a:t>
-            </a:r>
-            <a:r>
-              <a:rPr lang="uk-UA" noProof="0" dirty="0"/>
-              <a:t> використовується </a:t>
+              <a:t>— генерація рекомендацій. Досить часто використовується </a:t>
             </a:r>
             <a:r>
               <a:rPr lang="uk-UA" noProof="0" dirty="0" err="1"/>
@@ -7339,7 +7331,7 @@
           <a:p>
             <a:fld id="{C764DE79-268F-4C1A-8933-263129D2AF90}" type="datetimeFigureOut">
               <a:rPr lang="en-US" smtClean="0"/>
-              <a:t>5/6/2026</a:t>
+              <a:t>5/7/2026</a:t>
             </a:fld>
             <a:endParaRPr lang="en-US" dirty="0"/>
           </a:p>
@@ -7381,7 +7373,7 @@
           <a:p>
             <a:fld id="{48F63A3B-78C7-47BE-AE5E-E10140E04643}" type="slidenum">
               <a:rPr lang="en-US" smtClean="0"/>
-              <a:t>‹№›</a:t>
+              <a:t>‹#›</a:t>
             </a:fld>
             <a:endParaRPr lang="en-US" dirty="0"/>
           </a:p>
@@ -7510,7 +7502,7 @@
           <a:p>
             <a:fld id="{C764DE79-268F-4C1A-8933-263129D2AF90}" type="datetimeFigureOut">
               <a:rPr lang="en-US" smtClean="0"/>
-              <a:t>5/6/2026</a:t>
+              <a:t>5/7/2026</a:t>
             </a:fld>
             <a:endParaRPr lang="en-US" dirty="0"/>
           </a:p>
@@ -7552,7 +7544,7 @@
           <a:p>
             <a:fld id="{48F63A3B-78C7-47BE-AE5E-E10140E04643}" type="slidenum">
               <a:rPr lang="en-US" smtClean="0"/>
-              <a:t>‹№›</a:t>
+              <a:t>‹#›</a:t>
             </a:fld>
             <a:endParaRPr lang="en-US" dirty="0"/>
           </a:p>
@@ -7691,7 +7683,7 @@
           <a:p>
             <a:fld id="{C764DE79-268F-4C1A-8933-263129D2AF90}" type="datetimeFigureOut">
               <a:rPr lang="en-US" smtClean="0"/>
-              <a:t>5/6/2026</a:t>
+              <a:t>5/7/2026</a:t>
             </a:fld>
             <a:endParaRPr lang="en-US" dirty="0"/>
           </a:p>
@@ -7733,7 +7725,7 @@
           <a:p>
             <a:fld id="{48F63A3B-78C7-47BE-AE5E-E10140E04643}" type="slidenum">
               <a:rPr lang="en-US" smtClean="0"/>
-              <a:t>‹№›</a:t>
+              <a:t>‹#›</a:t>
             </a:fld>
             <a:endParaRPr lang="en-US" dirty="0"/>
           </a:p>
@@ -7897,7 +7889,7 @@
           <a:p>
             <a:fld id="{C764DE79-268F-4C1A-8933-263129D2AF90}" type="datetimeFigureOut">
               <a:rPr lang="en-US" smtClean="0"/>
-              <a:t>5/6/2026</a:t>
+              <a:t>5/7/2026</a:t>
             </a:fld>
             <a:endParaRPr lang="en-US" dirty="0"/>
           </a:p>
@@ -7939,7 +7931,7 @@
           <a:p>
             <a:fld id="{48F63A3B-78C7-47BE-AE5E-E10140E04643}" type="slidenum">
               <a:rPr lang="en-US" smtClean="0"/>
-              <a:t>‹№›</a:t>
+              <a:t>‹#›</a:t>
             </a:fld>
             <a:endParaRPr lang="en-US" dirty="0"/>
           </a:p>
@@ -8144,7 +8136,7 @@
           <a:p>
             <a:fld id="{C764DE79-268F-4C1A-8933-263129D2AF90}" type="datetimeFigureOut">
               <a:rPr lang="en-US" smtClean="0"/>
-              <a:t>5/6/2026</a:t>
+              <a:t>5/7/2026</a:t>
             </a:fld>
             <a:endParaRPr lang="en-US" dirty="0"/>
           </a:p>
@@ -8186,7 +8178,7 @@
           <a:p>
             <a:fld id="{48F63A3B-78C7-47BE-AE5E-E10140E04643}" type="slidenum">
               <a:rPr lang="en-US" smtClean="0"/>
-              <a:t>‹№›</a:t>
+              <a:t>‹#›</a:t>
             </a:fld>
             <a:endParaRPr lang="en-US" dirty="0"/>
           </a:p>
@@ -8377,7 +8369,7 @@
           <a:p>
             <a:fld id="{C764DE79-268F-4C1A-8933-263129D2AF90}" type="datetimeFigureOut">
               <a:rPr lang="en-US" smtClean="0"/>
-              <a:t>5/6/2026</a:t>
+              <a:t>5/7/2026</a:t>
             </a:fld>
             <a:endParaRPr lang="en-US" dirty="0"/>
           </a:p>
@@ -8419,7 +8411,7 @@
           <a:p>
             <a:fld id="{48F63A3B-78C7-47BE-AE5E-E10140E04643}" type="slidenum">
               <a:rPr lang="en-US" smtClean="0"/>
-              <a:t>‹№›</a:t>
+              <a:t>‹#›</a:t>
             </a:fld>
             <a:endParaRPr lang="en-US" dirty="0"/>
           </a:p>
@@ -8745,7 +8737,7 @@
           <a:p>
             <a:fld id="{C764DE79-268F-4C1A-8933-263129D2AF90}" type="datetimeFigureOut">
               <a:rPr lang="en-US" smtClean="0"/>
-              <a:t>5/6/2026</a:t>
+              <a:t>5/7/2026</a:t>
             </a:fld>
             <a:endParaRPr lang="en-US" dirty="0"/>
           </a:p>
@@ -8787,7 +8779,7 @@
           <a:p>
             <a:fld id="{48F63A3B-78C7-47BE-AE5E-E10140E04643}" type="slidenum">
               <a:rPr lang="en-US" smtClean="0"/>
-              <a:t>‹№›</a:t>
+              <a:t>‹#›</a:t>
             </a:fld>
             <a:endParaRPr lang="en-US" dirty="0"/>
           </a:p>
@@ -8864,7 +8856,7 @@
           <a:p>
             <a:fld id="{C764DE79-268F-4C1A-8933-263129D2AF90}" type="datetimeFigureOut">
               <a:rPr lang="en-US" smtClean="0"/>
-              <a:t>5/6/2026</a:t>
+              <a:t>5/7/2026</a:t>
             </a:fld>
             <a:endParaRPr lang="en-US" dirty="0"/>
           </a:p>
@@ -8906,7 +8898,7 @@
           <a:p>
             <a:fld id="{48F63A3B-78C7-47BE-AE5E-E10140E04643}" type="slidenum">
               <a:rPr lang="en-US" smtClean="0"/>
-              <a:t>‹№›</a:t>
+              <a:t>‹#›</a:t>
             </a:fld>
             <a:endParaRPr lang="en-US" dirty="0"/>
           </a:p>
@@ -8960,7 +8952,7 @@
           <a:p>
             <a:fld id="{C764DE79-268F-4C1A-8933-263129D2AF90}" type="datetimeFigureOut">
               <a:rPr lang="en-US" smtClean="0"/>
-              <a:t>5/6/2026</a:t>
+              <a:t>5/7/2026</a:t>
             </a:fld>
             <a:endParaRPr lang="en-US" dirty="0"/>
           </a:p>
@@ -9002,7 +8994,7 @@
           <a:p>
             <a:fld id="{48F63A3B-78C7-47BE-AE5E-E10140E04643}" type="slidenum">
               <a:rPr lang="en-US" smtClean="0"/>
-              <a:t>‹№›</a:t>
+              <a:t>‹#›</a:t>
             </a:fld>
             <a:endParaRPr lang="en-US" dirty="0"/>
           </a:p>
@@ -9238,7 +9230,7 @@
           <a:p>
             <a:fld id="{C764DE79-268F-4C1A-8933-263129D2AF90}" type="datetimeFigureOut">
               <a:rPr lang="en-US" smtClean="0"/>
-              <a:t>5/6/2026</a:t>
+              <a:t>5/7/2026</a:t>
             </a:fld>
             <a:endParaRPr lang="en-US" dirty="0"/>
           </a:p>
@@ -9280,7 +9272,7 @@
           <a:p>
             <a:fld id="{48F63A3B-78C7-47BE-AE5E-E10140E04643}" type="slidenum">
               <a:rPr lang="en-US" smtClean="0"/>
-              <a:t>‹№›</a:t>
+              <a:t>‹#›</a:t>
             </a:fld>
             <a:endParaRPr lang="en-US" dirty="0"/>
           </a:p>
@@ -9496,7 +9488,7 @@
           <a:p>
             <a:fld id="{C764DE79-268F-4C1A-8933-263129D2AF90}" type="datetimeFigureOut">
               <a:rPr lang="en-US" smtClean="0"/>
-              <a:t>5/6/2026</a:t>
+              <a:t>5/7/2026</a:t>
             </a:fld>
             <a:endParaRPr lang="en-US" dirty="0"/>
           </a:p>
@@ -9538,7 +9530,7 @@
           <a:p>
             <a:fld id="{48F63A3B-78C7-47BE-AE5E-E10140E04643}" type="slidenum">
               <a:rPr lang="en-US" smtClean="0"/>
-              <a:t>‹№›</a:t>
+              <a:t>‹#›</a:t>
             </a:fld>
             <a:endParaRPr lang="en-US" dirty="0"/>
           </a:p>
@@ -9710,7 +9702,7 @@
           <a:p>
             <a:fld id="{C764DE79-268F-4C1A-8933-263129D2AF90}" type="datetimeFigureOut">
               <a:rPr lang="en-US" smtClean="0"/>
-              <a:t>5/6/2026</a:t>
+              <a:t>5/7/2026</a:t>
             </a:fld>
             <a:endParaRPr lang="en-US" dirty="0"/>
           </a:p>
@@ -9788,7 +9780,7 @@
           <a:p>
             <a:fld id="{48F63A3B-78C7-47BE-AE5E-E10140E04643}" type="slidenum">
               <a:rPr lang="en-US" smtClean="0"/>
-              <a:t>‹№›</a:t>
+              <a:t>‹#›</a:t>
             </a:fld>
             <a:endParaRPr lang="en-US" dirty="0"/>
           </a:p>
@@ -15137,8 +15129,8 @@
         </p:nvSpPr>
         <p:spPr>
           <a:xfrm>
-            <a:off x="5943600" y="1316736"/>
-            <a:ext cx="2651760" cy="1042416"/>
+            <a:off x="5471160" y="1316736"/>
+            <a:ext cx="3124200" cy="1042416"/>
           </a:xfrm>
           <a:prstGeom prst="rect">
             <a:avLst/>
@@ -15183,7 +15175,51 @@
                 <a:ea typeface="Calibri" pitchFamily="34" charset="-122"/>
                 <a:cs typeface="Calibri" pitchFamily="34" charset="-120"/>
               </a:rPr>
-              <a:t>P — матриця users (m × k)</a:t>
+              <a:t>P — </a:t>
+            </a:r>
+            <a:r>
+              <a:rPr lang="en-US" sz="1400" dirty="0" err="1">
+                <a:solidFill>
+                  <a:schemeClr val="bg1"/>
+                </a:solidFill>
+                <a:latin typeface="Calibri" pitchFamily="34" charset="0"/>
+                <a:ea typeface="Calibri" pitchFamily="34" charset="-122"/>
+                <a:cs typeface="Calibri" pitchFamily="34" charset="-120"/>
+              </a:rPr>
+              <a:t>матриця</a:t>
+            </a:r>
+            <a:r>
+              <a:rPr lang="en-US" sz="1400" dirty="0">
+                <a:solidFill>
+                  <a:schemeClr val="bg1"/>
+                </a:solidFill>
+                <a:latin typeface="Calibri" pitchFamily="34" charset="0"/>
+                <a:ea typeface="Calibri" pitchFamily="34" charset="-122"/>
+                <a:cs typeface="Calibri" pitchFamily="34" charset="-120"/>
+              </a:rPr>
+              <a:t> </a:t>
+            </a:r>
+            <a:r>
+              <a:rPr lang="uk-UA" sz="1400" dirty="0">
+                <a:solidFill>
+                  <a:schemeClr val="bg1"/>
+                </a:solidFill>
+                <a:latin typeface="Calibri" pitchFamily="34" charset="0"/>
+                <a:ea typeface="Calibri" pitchFamily="34" charset="-122"/>
+                <a:cs typeface="Calibri" pitchFamily="34" charset="-120"/>
+              </a:rPr>
+              <a:t>користувачів</a:t>
+            </a:r>
+            <a:r>
+              <a:rPr lang="en-US" sz="1400" dirty="0">
+                <a:solidFill>
+                  <a:schemeClr val="bg1"/>
+                </a:solidFill>
+                <a:latin typeface="Calibri" pitchFamily="34" charset="0"/>
+                <a:ea typeface="Calibri" pitchFamily="34" charset="-122"/>
+                <a:cs typeface="Calibri" pitchFamily="34" charset="-120"/>
+              </a:rPr>
+              <a:t> (m × k)</a:t>
             </a:r>
             <a:endParaRPr lang="en-US" sz="1400" dirty="0">
               <a:solidFill>
@@ -15204,7 +15240,51 @@
                 <a:ea typeface="Calibri" pitchFamily="34" charset="-122"/>
                 <a:cs typeface="Calibri" pitchFamily="34" charset="-120"/>
               </a:rPr>
-              <a:t>Q — матриця items (n × k)</a:t>
+              <a:t>Q — </a:t>
+            </a:r>
+            <a:r>
+              <a:rPr lang="en-US" sz="1400" dirty="0" err="1">
+                <a:solidFill>
+                  <a:schemeClr val="bg1"/>
+                </a:solidFill>
+                <a:latin typeface="Calibri" pitchFamily="34" charset="0"/>
+                <a:ea typeface="Calibri" pitchFamily="34" charset="-122"/>
+                <a:cs typeface="Calibri" pitchFamily="34" charset="-120"/>
+              </a:rPr>
+              <a:t>матриця</a:t>
+            </a:r>
+            <a:r>
+              <a:rPr lang="en-US" sz="1400" dirty="0">
+                <a:solidFill>
+                  <a:schemeClr val="bg1"/>
+                </a:solidFill>
+                <a:latin typeface="Calibri" pitchFamily="34" charset="0"/>
+                <a:ea typeface="Calibri" pitchFamily="34" charset="-122"/>
+                <a:cs typeface="Calibri" pitchFamily="34" charset="-120"/>
+              </a:rPr>
+              <a:t> </a:t>
+            </a:r>
+            <a:r>
+              <a:rPr lang="uk-UA" sz="1400" dirty="0">
+                <a:solidFill>
+                  <a:schemeClr val="bg1"/>
+                </a:solidFill>
+                <a:latin typeface="Calibri" pitchFamily="34" charset="0"/>
+                <a:ea typeface="Calibri" pitchFamily="34" charset="-122"/>
+                <a:cs typeface="Calibri" pitchFamily="34" charset="-120"/>
+              </a:rPr>
+              <a:t>елементів</a:t>
+            </a:r>
+            <a:r>
+              <a:rPr lang="en-US" sz="1400" dirty="0">
+                <a:solidFill>
+                  <a:schemeClr val="bg1"/>
+                </a:solidFill>
+                <a:latin typeface="Calibri" pitchFamily="34" charset="0"/>
+                <a:ea typeface="Calibri" pitchFamily="34" charset="-122"/>
+                <a:cs typeface="Calibri" pitchFamily="34" charset="-120"/>
+              </a:rPr>
+              <a:t> (n × k)</a:t>
             </a:r>
             <a:endParaRPr lang="en-US" sz="1400" dirty="0">
               <a:solidFill>
@@ -15225,7 +15305,40 @@
                 <a:ea typeface="Calibri" pitchFamily="34" charset="-122"/>
                 <a:cs typeface="Calibri" pitchFamily="34" charset="-120"/>
               </a:rPr>
-              <a:t>k — кількість latent factors</a:t>
+              <a:t>k — </a:t>
+            </a:r>
+            <a:r>
+              <a:rPr lang="en-US" sz="1400" dirty="0" err="1">
+                <a:solidFill>
+                  <a:schemeClr val="bg1"/>
+                </a:solidFill>
+                <a:latin typeface="Calibri" pitchFamily="34" charset="0"/>
+                <a:ea typeface="Calibri" pitchFamily="34" charset="-122"/>
+                <a:cs typeface="Calibri" pitchFamily="34" charset="-120"/>
+              </a:rPr>
+              <a:t>кількість</a:t>
+            </a:r>
+            <a:r>
+              <a:rPr lang="en-US" sz="1400" dirty="0">
+                <a:solidFill>
+                  <a:schemeClr val="bg1"/>
+                </a:solidFill>
+                <a:latin typeface="Calibri" pitchFamily="34" charset="0"/>
+                <a:ea typeface="Calibri" pitchFamily="34" charset="-122"/>
+                <a:cs typeface="Calibri" pitchFamily="34" charset="-120"/>
+              </a:rPr>
+              <a:t> </a:t>
+            </a:r>
+            <a:r>
+              <a:rPr lang="uk-UA" sz="1400" dirty="0">
+                <a:solidFill>
+                  <a:schemeClr val="bg1"/>
+                </a:solidFill>
+                <a:latin typeface="Calibri" pitchFamily="34" charset="0"/>
+                <a:ea typeface="Calibri" pitchFamily="34" charset="-122"/>
+                <a:cs typeface="Calibri" pitchFamily="34" charset="-120"/>
+              </a:rPr>
+              <a:t>факторів</a:t>
             </a:r>
             <a:endParaRPr lang="en-US" sz="1400" dirty="0">
               <a:solidFill>
@@ -19751,7 +19864,29 @@
                 <a:ea typeface="Calibri" pitchFamily="34" charset="-122"/>
                 <a:cs typeface="Calibri" pitchFamily="34" charset="-120"/>
               </a:rPr>
-              <a:t>ML підходи в industry:</a:t>
+              <a:t>ML підходи в </a:t>
+            </a:r>
+            <a:r>
+              <a:rPr lang="uk-UA" sz="1300" b="1" dirty="0">
+                <a:solidFill>
+                  <a:srgbClr val="0D9488"/>
+                </a:solidFill>
+                <a:latin typeface="Calibri" pitchFamily="34" charset="0"/>
+                <a:ea typeface="Calibri" pitchFamily="34" charset="-122"/>
+                <a:cs typeface="Calibri" pitchFamily="34" charset="-120"/>
+              </a:rPr>
+              <a:t>індустрії</a:t>
+            </a:r>
+            <a:r>
+              <a:rPr lang="en-US" sz="1300" b="1" dirty="0">
+                <a:solidFill>
+                  <a:srgbClr val="0D9488"/>
+                </a:solidFill>
+                <a:latin typeface="Calibri" pitchFamily="34" charset="0"/>
+                <a:ea typeface="Calibri" pitchFamily="34" charset="-122"/>
+                <a:cs typeface="Calibri" pitchFamily="34" charset="-120"/>
+              </a:rPr>
+              <a:t>:</a:t>
             </a:r>
             <a:endParaRPr lang="en-US" sz="1300" dirty="0"/>
           </a:p>
@@ -21175,7 +21310,7 @@
                 <a:ea typeface="Calibri" pitchFamily="34" charset="-122"/>
                 <a:cs typeface="Calibri" pitchFamily="34" charset="-120"/>
               </a:rPr>
-              <a:t>пошук Google/Bing, рекомендації LinkedIn, Twitter</a:t>
+              <a:t>пошук Google/Bing, рекомендації LinkedIn, X</a:t>
             </a:r>
             <a:endParaRPr lang="en-US" sz="1250" dirty="0"/>
           </a:p>
@@ -23852,7 +23987,40 @@
                 <a:ea typeface="Calibri" pitchFamily="34" charset="-122"/>
                 <a:cs typeface="Calibri" pitchFamily="34" charset="-120"/>
               </a:rPr>
-              <a:t>: механізм уваги вибирає важливі попередні items</a:t>
+              <a:t>: механізм уваги вибирає важливі </a:t>
+            </a:r>
+            <a:r>
+              <a:rPr lang="en-US" sz="1050" dirty="0" err="1">
+                <a:solidFill>
+                  <a:srgbClr val="334155"/>
+                </a:solidFill>
+                <a:latin typeface="Calibri" pitchFamily="34" charset="0"/>
+                <a:ea typeface="Calibri" pitchFamily="34" charset="-122"/>
+                <a:cs typeface="Calibri" pitchFamily="34" charset="-120"/>
+              </a:rPr>
+              <a:t>попередні</a:t>
+            </a:r>
+            <a:r>
+              <a:rPr lang="en-US" sz="1050" dirty="0">
+                <a:solidFill>
+                  <a:srgbClr val="334155"/>
+                </a:solidFill>
+                <a:latin typeface="Calibri" pitchFamily="34" charset="0"/>
+                <a:ea typeface="Calibri" pitchFamily="34" charset="-122"/>
+                <a:cs typeface="Calibri" pitchFamily="34" charset="-120"/>
+              </a:rPr>
+              <a:t> </a:t>
+            </a:r>
+            <a:r>
+              <a:rPr lang="uk-UA" sz="1050" dirty="0">
+                <a:solidFill>
+                  <a:srgbClr val="334155"/>
+                </a:solidFill>
+                <a:latin typeface="Calibri" pitchFamily="34" charset="0"/>
+                <a:ea typeface="Calibri" pitchFamily="34" charset="-122"/>
+                <a:cs typeface="Calibri" pitchFamily="34" charset="-120"/>
+              </a:rPr>
+              <a:t>елементи</a:t>
             </a:r>
             <a:endParaRPr lang="en-US" sz="1050" dirty="0"/>
           </a:p>
@@ -44020,7 +44188,51 @@
                 <a:ea typeface="Calibri" pitchFamily="34" charset="-122"/>
                 <a:cs typeface="Calibri" pitchFamily="34" charset="-120"/>
               </a:rPr>
-              <a:t>Precision@k — частка релевантних items серед перших k рекомендацій, незалежно від позиції</a:t>
+              <a:t>Precision@k — частка </a:t>
+            </a:r>
+            <a:r>
+              <a:rPr lang="en-US" sz="1300" dirty="0" err="1">
+                <a:solidFill>
+                  <a:srgbClr val="334155"/>
+                </a:solidFill>
+                <a:latin typeface="Calibri" pitchFamily="34" charset="0"/>
+                <a:ea typeface="Calibri" pitchFamily="34" charset="-122"/>
+                <a:cs typeface="Calibri" pitchFamily="34" charset="-120"/>
+              </a:rPr>
+              <a:t>релевантних</a:t>
+            </a:r>
+            <a:r>
+              <a:rPr lang="en-US" sz="1300" dirty="0">
+                <a:solidFill>
+                  <a:srgbClr val="334155"/>
+                </a:solidFill>
+                <a:latin typeface="Calibri" pitchFamily="34" charset="0"/>
+                <a:ea typeface="Calibri" pitchFamily="34" charset="-122"/>
+                <a:cs typeface="Calibri" pitchFamily="34" charset="-120"/>
+              </a:rPr>
+              <a:t> </a:t>
+            </a:r>
+            <a:r>
+              <a:rPr lang="uk-UA" sz="1300" dirty="0">
+                <a:solidFill>
+                  <a:srgbClr val="334155"/>
+                </a:solidFill>
+                <a:latin typeface="Calibri" pitchFamily="34" charset="0"/>
+                <a:ea typeface="Calibri" pitchFamily="34" charset="-122"/>
+                <a:cs typeface="Calibri" pitchFamily="34" charset="-120"/>
+              </a:rPr>
+              <a:t>елементів</a:t>
+            </a:r>
+            <a:r>
+              <a:rPr lang="en-US" sz="1300" dirty="0">
+                <a:solidFill>
+                  <a:srgbClr val="334155"/>
+                </a:solidFill>
+                <a:latin typeface="Calibri" pitchFamily="34" charset="0"/>
+                <a:ea typeface="Calibri" pitchFamily="34" charset="-122"/>
+                <a:cs typeface="Calibri" pitchFamily="34" charset="-120"/>
+              </a:rPr>
+              <a:t> серед перших k рекомендацій, незалежно від позиції</a:t>
             </a:r>
             <a:endParaRPr lang="en-US" sz="1300" dirty="0"/>
           </a:p>
@@ -44196,9 +44408,6 @@
           <a:bodyPr wrap="square" rtlCol="0" anchor="ctr"/>
           <a:lstStyle/>
           <a:p>
-            <a:pPr marL="0" indent="0">
-              <a:buNone/>
-            </a:pPr>
             <a:r>
               <a:rPr lang="en-US" sz="1300" dirty="0">
                 <a:solidFill>
@@ -44208,7 +44417,51 @@
                 <a:ea typeface="Calibri" pitchFamily="34" charset="-122"/>
                 <a:cs typeface="Calibri" pitchFamily="34" charset="-120"/>
               </a:rPr>
-              <a:t>Recall@k — частка знайдених релевантних items від загальної їх кількості у каталозі</a:t>
+              <a:t>Recall@k — частка знайдених </a:t>
+            </a:r>
+            <a:r>
+              <a:rPr lang="en-US" sz="1300" dirty="0" err="1">
+                <a:solidFill>
+                  <a:srgbClr val="334155"/>
+                </a:solidFill>
+                <a:latin typeface="Calibri" pitchFamily="34" charset="0"/>
+                <a:ea typeface="Calibri" pitchFamily="34" charset="-122"/>
+                <a:cs typeface="Calibri" pitchFamily="34" charset="-120"/>
+              </a:rPr>
+              <a:t>релевантних</a:t>
+            </a:r>
+            <a:r>
+              <a:rPr lang="en-US" sz="1300" dirty="0">
+                <a:solidFill>
+                  <a:srgbClr val="334155"/>
+                </a:solidFill>
+                <a:latin typeface="Calibri" pitchFamily="34" charset="0"/>
+                <a:ea typeface="Calibri" pitchFamily="34" charset="-122"/>
+                <a:cs typeface="Calibri" pitchFamily="34" charset="-120"/>
+              </a:rPr>
+              <a:t> </a:t>
+            </a:r>
+            <a:r>
+              <a:rPr lang="uk-UA" sz="1300" dirty="0">
+                <a:solidFill>
+                  <a:srgbClr val="334155"/>
+                </a:solidFill>
+                <a:latin typeface="Calibri" pitchFamily="34" charset="0"/>
+                <a:ea typeface="Calibri" pitchFamily="34" charset="-122"/>
+                <a:cs typeface="Calibri" pitchFamily="34" charset="-120"/>
+              </a:rPr>
+              <a:t>елементів</a:t>
+            </a:r>
+            <a:r>
+              <a:rPr lang="en-US" sz="1300" dirty="0">
+                <a:solidFill>
+                  <a:srgbClr val="334155"/>
+                </a:solidFill>
+                <a:latin typeface="Calibri" pitchFamily="34" charset="0"/>
+                <a:ea typeface="Calibri" pitchFamily="34" charset="-122"/>
+                <a:cs typeface="Calibri" pitchFamily="34" charset="-120"/>
+              </a:rPr>
+              <a:t> від загальної їх кількості у каталозі</a:t>
             </a:r>
             <a:endParaRPr lang="en-US" sz="1300" dirty="0"/>
           </a:p>
@@ -44584,7 +44837,51 @@
                 <a:ea typeface="Calibri" pitchFamily="34" charset="-122"/>
                 <a:cs typeface="Calibri" pitchFamily="34" charset="-120"/>
               </a:rPr>
-              <a:t>Hit Rate@k — бінарна метрика: чи потрапив хоча б один релевантний item у top-k</a:t>
+              <a:t>Hit Rate@k — бінарна метрика: чи потрапив хоча б один </a:t>
+            </a:r>
+            <a:r>
+              <a:rPr lang="en-US" sz="1300" dirty="0" err="1">
+                <a:solidFill>
+                  <a:srgbClr val="334155"/>
+                </a:solidFill>
+                <a:latin typeface="Calibri" pitchFamily="34" charset="0"/>
+                <a:ea typeface="Calibri" pitchFamily="34" charset="-122"/>
+                <a:cs typeface="Calibri" pitchFamily="34" charset="-120"/>
+              </a:rPr>
+              <a:t>релевантний</a:t>
+            </a:r>
+            <a:r>
+              <a:rPr lang="en-US" sz="1300" dirty="0">
+                <a:solidFill>
+                  <a:srgbClr val="334155"/>
+                </a:solidFill>
+                <a:latin typeface="Calibri" pitchFamily="34" charset="0"/>
+                <a:ea typeface="Calibri" pitchFamily="34" charset="-122"/>
+                <a:cs typeface="Calibri" pitchFamily="34" charset="-120"/>
+              </a:rPr>
+              <a:t> </a:t>
+            </a:r>
+            <a:r>
+              <a:rPr lang="uk-UA" sz="1300" dirty="0">
+                <a:solidFill>
+                  <a:srgbClr val="334155"/>
+                </a:solidFill>
+                <a:latin typeface="Calibri" pitchFamily="34" charset="0"/>
+                <a:ea typeface="Calibri" pitchFamily="34" charset="-122"/>
+                <a:cs typeface="Calibri" pitchFamily="34" charset="-120"/>
+              </a:rPr>
+              <a:t>елемент</a:t>
+            </a:r>
+            <a:r>
+              <a:rPr lang="en-US" sz="1300" dirty="0">
+                <a:solidFill>
+                  <a:srgbClr val="334155"/>
+                </a:solidFill>
+                <a:latin typeface="Calibri" pitchFamily="34" charset="0"/>
+                <a:ea typeface="Calibri" pitchFamily="34" charset="-122"/>
+                <a:cs typeface="Calibri" pitchFamily="34" charset="-120"/>
+              </a:rPr>
+              <a:t> у top-k</a:t>
             </a:r>
             <a:endParaRPr lang="en-US" sz="1300" dirty="0"/>
           </a:p>
@@ -44840,7 +45137,23 @@
                 <a:ea typeface="Calibri" pitchFamily="34" charset="-122"/>
                 <a:cs typeface="Calibri" pitchFamily="34" charset="-120"/>
               </a:rPr>
-              <a:t>✔  Правильна відповідь: В — NDCG@k дисконтує прибуток за log2(позиція+1): item </a:t>
+              <a:t>✔  Правильна відповідь: В — NDCG@k дисконтує прибуток за log2(позиція+1): </a:t>
+            </a:r>
+            <a:r>
+              <a:rPr lang="uk-UA" sz="1150" dirty="0">
+                <a:latin typeface="Calibri" pitchFamily="34" charset="0"/>
+                <a:ea typeface="Calibri" pitchFamily="34" charset="-122"/>
+                <a:cs typeface="Calibri" pitchFamily="34" charset="-120"/>
+              </a:rPr>
+              <a:t>елемент</a:t>
+            </a:r>
+            <a:r>
+              <a:rPr lang="en-US" sz="1150" dirty="0">
+                <a:latin typeface="Calibri" pitchFamily="34" charset="0"/>
+                <a:ea typeface="Calibri" pitchFamily="34" charset="-122"/>
+                <a:cs typeface="Calibri" pitchFamily="34" charset="-120"/>
+              </a:rPr>
+              <a:t> </a:t>
             </a:r>
             <a:r>
               <a:rPr lang="en-US" sz="1150" dirty="0" err="1">

</xml_diff>